<commit_message>
decks: Lesson 5 Body Paragraphs, house analogy as a usable slide
All 24 of Brian's slides plus a current editor screenshot on the Body
Paragraphs step. His title-only "House Analogy" slide becomes the four
stops on the slide (neighborhood, front door, rooms, back at the door),
with his telling in the notes. Four long steps now lay out as a 2 x 2
grid, and long sample passages size down to fit.

Co-Authored-By: Claude Opus 5.5 <noreply@anthropic.com>
Claude-Session: https://claude.ai/code/session_01UdRZiPuGfgyCyhqFn7imqw
</commit_message>
<xml_diff>
--- a/services/web-app/resources/thesis-essay-decks/lesson-4-introduction.pptx
+++ b/services/web-app/resources/thesis-essay-decks/lesson-4-introduction.pptx
@@ -10148,7 +10148,7 @@
               <a:buNone/>
             </a:pPr>
             <a:r>
-              <a:rPr lang="en-US" sz="1850" dirty="0">
+              <a:rPr lang="en-US" sz="1500" dirty="0">
                 <a:solidFill>
                   <a:srgbClr val="3C3828"/>
                 </a:solidFill>
@@ -10165,7 +10165,7 @@
               <a:buNone/>
             </a:pPr>
             <a:r>
-              <a:rPr lang="en-US" sz="1850" i="1" dirty="0">
+              <a:rPr lang="en-US" sz="1500" i="1" dirty="0">
                 <a:solidFill>
                   <a:srgbClr val="3C3828"/>
                 </a:solidFill>
@@ -10175,7 +10175,7 @@
               </a:rPr>
               <a:t>When schools fail to prioritize creativity in teaching, school becomes boring for both students and teachers, resulting in a lack of shared motivation, excitement, and accomplishment.</a:t>
             </a:r>
-            <a:endParaRPr lang="en-US" sz="1850" dirty="0"/>
+            <a:endParaRPr lang="en-US" sz="1500" dirty="0"/>
           </a:p>
         </p:txBody>
       </p:sp>
@@ -10456,7 +10456,7 @@
               <a:buNone/>
             </a:pPr>
             <a:r>
-              <a:rPr lang="en-US" sz="1850" dirty="0">
+              <a:rPr lang="en-US" sz="1700" dirty="0">
                 <a:solidFill>
                   <a:srgbClr val="3C3828"/>
                 </a:solidFill>
@@ -10473,7 +10473,7 @@
               <a:buNone/>
             </a:pPr>
             <a:r>
-              <a:rPr lang="en-US" sz="1850" i="1" dirty="0">
+              <a:rPr lang="en-US" sz="1700" i="1" dirty="0">
                 <a:solidFill>
                   <a:srgbClr val="3C3828"/>
                 </a:solidFill>
@@ -10483,7 +10483,7 @@
               </a:rPr>
               <a:t>When schools fail to prioritize creativity in teaching, school becomes boring for both students and teachers, resulting in a lack of shared motivation, excitement, and accomplishment.</a:t>
             </a:r>
-            <a:endParaRPr lang="en-US" sz="1850" dirty="0"/>
+            <a:endParaRPr lang="en-US" sz="1700" dirty="0"/>
           </a:p>
         </p:txBody>
       </p:sp>
@@ -11588,7 +11588,7 @@
               <a:buNone/>
             </a:pPr>
             <a:r>
-              <a:rPr lang="en-US" sz="1850" dirty="0">
+              <a:rPr lang="en-US" sz="1700" dirty="0">
                 <a:solidFill>
                   <a:srgbClr val="3C3828"/>
                 </a:solidFill>
@@ -11605,7 +11605,7 @@
               <a:buNone/>
             </a:pPr>
             <a:r>
-              <a:rPr lang="en-US" sz="1850" i="1" dirty="0">
+              <a:rPr lang="en-US" sz="1700" i="1" dirty="0">
                 <a:solidFill>
                   <a:srgbClr val="3C3828"/>
                 </a:solidFill>
@@ -11615,7 +11615,7 @@
               </a:rPr>
               <a:t>When schools fail to prioritize creativity in teaching, school becomes boring for both students and teachers, resulting in a lack of shared motivation, excitement, and accomplishment.</a:t>
             </a:r>
-            <a:endParaRPr lang="en-US" sz="1850" dirty="0"/>
+            <a:endParaRPr lang="en-US" sz="1700" dirty="0"/>
           </a:p>
         </p:txBody>
       </p:sp>
@@ -11896,7 +11896,7 @@
               <a:buNone/>
             </a:pPr>
             <a:r>
-              <a:rPr lang="en-US" sz="1850" dirty="0">
+              <a:rPr lang="en-US" sz="1500" dirty="0">
                 <a:solidFill>
                   <a:srgbClr val="3C3828"/>
                 </a:solidFill>
@@ -11913,7 +11913,7 @@
               <a:buNone/>
             </a:pPr>
             <a:r>
-              <a:rPr lang="en-US" sz="1850" i="1" dirty="0">
+              <a:rPr lang="en-US" sz="1500" i="1" dirty="0">
                 <a:solidFill>
                   <a:srgbClr val="3C3828"/>
                 </a:solidFill>
@@ -11923,7 +11923,7 @@
               </a:rPr>
               <a:t>When schools fail to prioritize creativity in teaching, school becomes boring for both students and teachers, resulting in a lack of shared motivation, excitement, and accomplishment.</a:t>
             </a:r>
-            <a:endParaRPr lang="en-US" sz="1850" dirty="0"/>
+            <a:endParaRPr lang="en-US" sz="1500" dirty="0"/>
           </a:p>
         </p:txBody>
       </p:sp>

</xml_diff>